<commit_message>
Refresh Tuesday edition with pandas, tide and Mid-Autumn moon
- Update panda photo to the September 27 Atlanta-bound charter
- Add tide and Mid-Autumn moon photos for the September 28-27 stories
- Rewrite cards and PPT with simple sentences and image captions
- Keep sharing date, weekday and Shanghai weather in the top-right

Co-Authored-By: Claude <noreply@anthropic.com>
</commit_message>
<xml_diff>
--- a/daily-news/2026-09-29/今日新闻-2026-09-29.pptx
+++ b/daily-news/2026-09-29/今日新闻-2026-09-29.pptx
@@ -6,7 +6,6 @@
   </p:sldMasterIdLst>
   <p:sldIdLst>
     <p:sldId id="256" r:id="rId7"/>
-    <p:sldId id="257" r:id="rId8"/>
   </p:sldIdLst>
   <p:sldSz cx="12191695" cy="6858000" type="screen4x3"/>
   <p:notesSz cx="6858000" cy="9144000"/>
@@ -3252,7 +3251,7 @@
                 <a:latin typeface="PingFang SC"/>
                 <a:ea typeface="PingFang SC"/>
               </a:rPr>
-              <a:t>9月29日 星期二　上海 阴天 21—25℃，可能有小雨</a:t>
+              <a:t>9月29日 星期二　上海 小雨 22—26℃</a:t>
             </a:r>
           </a:p>
         </p:txBody>
@@ -3265,8 +3264,8 @@
         </p:nvSpPr>
         <p:spPr>
           <a:xfrm>
-            <a:off x="566928" y="1143000"/>
-            <a:ext cx="5303520" cy="4983480"/>
+            <a:off x="502920" y="1143000"/>
+            <a:ext cx="3657600" cy="4983480"/>
           </a:xfrm>
           <a:prstGeom prst="roundRect">
             <a:avLst/>
@@ -3311,15 +3310,15 @@
         </p:nvPicPr>
         <p:blipFill>
           <a:blip r:embed="rId2"/>
-          <a:srcRect t="5880" b="5880"/>
+          <a:srcRect t="649" b="649"/>
           <a:stretch>
             <a:fillRect/>
           </a:stretch>
         </p:blipFill>
         <p:spPr>
           <a:xfrm>
-            <a:off x="713232" y="1298448"/>
-            <a:ext cx="5010912" cy="2487168"/>
+            <a:off x="649224" y="1298448"/>
+            <a:ext cx="3364992" cy="2212848"/>
           </a:xfrm>
           <a:prstGeom prst="rect">
             <a:avLst/>
@@ -3334,7 +3333,7 @@
         </p:nvSpPr>
         <p:spPr>
           <a:xfrm>
-            <a:off x="859536" y="1444752"/>
+            <a:off x="795528" y="1444752"/>
             <a:ext cx="502920" cy="502920"/>
           </a:xfrm>
           <a:prstGeom prst="roundRect">
@@ -3378,7 +3377,7 @@
         </p:nvSpPr>
         <p:spPr>
           <a:xfrm>
-            <a:off x="859536" y="1572768"/>
+            <a:off x="795528" y="1572768"/>
             <a:ext cx="502920" cy="219456"/>
           </a:xfrm>
           <a:prstGeom prst="rect">
@@ -3418,8 +3417,8 @@
         </p:nvSpPr>
         <p:spPr>
           <a:xfrm>
-            <a:off x="914400" y="3337560"/>
-            <a:ext cx="4617720" cy="347472"/>
+            <a:off x="649224" y="3035808"/>
+            <a:ext cx="3364992" cy="365760"/>
           </a:xfrm>
           <a:prstGeom prst="roundRect">
             <a:avLst/>
@@ -3462,8 +3461,8 @@
         </p:nvSpPr>
         <p:spPr>
           <a:xfrm>
-            <a:off x="1024128" y="3419856"/>
-            <a:ext cx="4389120" cy="164592"/>
+            <a:off x="758952" y="3108960"/>
+            <a:ext cx="3154680" cy="201168"/>
           </a:xfrm>
           <a:prstGeom prst="rect">
             <a:avLst/>
@@ -3489,7 +3488,7 @@
                 <a:latin typeface="PingFang SC"/>
                 <a:ea typeface="PingFang SC"/>
               </a:rPr>
-              <a:t>图里：熊猫的新家</a:t>
+              <a:t>图里：熊猫正坐大飞机去新家</a:t>
             </a:r>
           </a:p>
         </p:txBody>
@@ -3502,8 +3501,8 @@
         </p:nvSpPr>
         <p:spPr>
           <a:xfrm>
-            <a:off x="822960" y="3977639"/>
-            <a:ext cx="4754880" cy="457200"/>
+            <a:off x="667512" y="3611880"/>
+            <a:ext cx="3337560" cy="777240"/>
           </a:xfrm>
           <a:prstGeom prst="rect">
             <a:avLst/>
@@ -3522,14 +3521,14 @@
               </a:spcAft>
             </a:pPr>
             <a:r>
-              <a:rPr sz="2500" b="1">
+              <a:rPr sz="2200" b="1">
                 <a:solidFill>
                   <a:srgbClr val="26384A"/>
                 </a:solidFill>
                 <a:latin typeface="PingFang SC"/>
                 <a:ea typeface="PingFang SC"/>
               </a:rPr>
-              <a:t>熊猫坐飞机</a:t>
+              <a:t>熊猫平平福双坐飞机去美国</a:t>
             </a:r>
           </a:p>
         </p:txBody>
@@ -3542,8 +3541,8 @@
         </p:nvSpPr>
         <p:spPr>
           <a:xfrm>
-            <a:off x="822960" y="4507992"/>
-            <a:ext cx="4754880" cy="640080"/>
+            <a:off x="667512" y="4416552"/>
+            <a:ext cx="3337560" cy="1280160"/>
           </a:xfrm>
           <a:prstGeom prst="rect">
             <a:avLst/>
@@ -3562,75 +3561,36 @@
               </a:spcAft>
             </a:pPr>
             <a:r>
-              <a:rPr sz="1900" b="0">
+              <a:rPr sz="1600" b="0">
                 <a:solidFill>
                   <a:srgbClr val="26384A"/>
                 </a:solidFill>
                 <a:latin typeface="PingFang SC"/>
                 <a:ea typeface="PingFang SC"/>
               </a:rPr>
-              <a:t>平平和福双到了新家。
-它们先要好好休息。</a:t>
-            </a:r>
-          </a:p>
-        </p:txBody>
-      </p:sp>
-      <p:sp>
-        <p:nvSpPr>
-          <p:cNvPr id="14" name="TextBox 13"/>
-          <p:cNvSpPr txBox="1"/>
-          <p:nvPr/>
-        </p:nvSpPr>
-        <p:spPr>
-          <a:xfrm>
-            <a:off x="822960" y="5367528"/>
-            <a:ext cx="4754880" cy="320040"/>
-          </a:xfrm>
-          <a:prstGeom prst="rect">
-            <a:avLst/>
-          </a:prstGeom>
-          <a:noFill/>
-        </p:spPr>
-        <p:txBody>
-          <a:bodyPr wrap="square" lIns="36576" rIns="36576" tIns="27432" bIns="27432">
-            <a:noAutofit/>
-          </a:bodyPr>
-          <a:lstStyle/>
-          <a:p>
-            <a:pPr algn="l">
-              <a:spcAft>
-                <a:spcPts val="0"/>
-              </a:spcAft>
-            </a:pPr>
-            <a:r>
-              <a:rPr sz="1600" b="1">
-                <a:solidFill>
-                  <a:srgbClr val="FF6475"/>
-                </a:solidFill>
-                <a:latin typeface="PingFang SC"/>
-                <a:ea typeface="PingFang SC"/>
-              </a:rPr>
-              <a:t>你想送熊猫什么礼物？</a:t>
-            </a:r>
-          </a:p>
-        </p:txBody>
-      </p:sp>
-      <p:sp>
-        <p:nvSpPr>
-          <p:cNvPr id="15" name="Rounded Rectangle 14"/>
+              <a:t>它们从成都出发，
+飞到美国的新动物园。
+先好好休息，再见面。</a:t>
+            </a:r>
+          </a:p>
+        </p:txBody>
+      </p:sp>
+      <p:sp>
+        <p:nvSpPr>
+          <p:cNvPr id="14" name="Rounded Rectangle 13"/>
           <p:cNvSpPr/>
           <p:nvPr/>
         </p:nvSpPr>
         <p:spPr>
           <a:xfrm>
-            <a:off x="6309360" y="1143000"/>
-            <a:ext cx="5303520" cy="4983480"/>
+            <a:off x="667512" y="5486400"/>
+            <a:ext cx="3337560" cy="457200"/>
           </a:xfrm>
           <a:prstGeom prst="roundRect">
             <a:avLst/>
           </a:prstGeom>
           <a:solidFill>
-            <a:srgbClr val="EAF5FF"/>
+            <a:srgbClr val="FFFFFF"/>
           </a:solidFill>
           <a:ln>
             <a:noFill/>
@@ -3659,47 +3619,62 @@
           </a:p>
         </p:txBody>
       </p:sp>
-      <p:pic>
-        <p:nvPicPr>
-          <p:cNvPr id="16" name="Picture 15" descr="science-letters.jpg"/>
-          <p:cNvPicPr>
-            <a:picLocks noChangeAspect="1"/>
-          </p:cNvPicPr>
+      <p:sp>
+        <p:nvSpPr>
+          <p:cNvPr id="15" name="TextBox 14"/>
+          <p:cNvSpPr txBox="1"/>
           <p:nvPr/>
-        </p:nvPicPr>
-        <p:blipFill>
-          <a:blip r:embed="rId3"/>
-          <a:srcRect t="10917" b="10917"/>
-          <a:stretch>
-            <a:fillRect/>
-          </a:stretch>
-        </p:blipFill>
-        <p:spPr>
-          <a:xfrm>
-            <a:off x="6455664" y="1298448"/>
-            <a:ext cx="5010912" cy="2487168"/>
+        </p:nvSpPr>
+        <p:spPr>
+          <a:xfrm>
+            <a:off x="758952" y="5596128"/>
+            <a:ext cx="3154680" cy="256032"/>
           </a:xfrm>
           <a:prstGeom prst="rect">
             <a:avLst/>
           </a:prstGeom>
-        </p:spPr>
-      </p:pic>
-      <p:sp>
-        <p:nvSpPr>
-          <p:cNvPr id="17" name="Rounded Rectangle 16"/>
+          <a:noFill/>
+        </p:spPr>
+        <p:txBody>
+          <a:bodyPr wrap="square" lIns="36576" rIns="36576" tIns="27432" bIns="27432">
+            <a:noAutofit/>
+          </a:bodyPr>
+          <a:lstStyle/>
+          <a:p>
+            <a:pPr algn="l">
+              <a:spcAft>
+                <a:spcPts val="0"/>
+              </a:spcAft>
+            </a:pPr>
+            <a:r>
+              <a:rPr sz="1500" b="1">
+                <a:solidFill>
+                  <a:srgbClr val="FF6475"/>
+                </a:solidFill>
+                <a:latin typeface="PingFang SC"/>
+                <a:ea typeface="PingFang SC"/>
+              </a:rPr>
+              <a:t>你想给它们说什么？</a:t>
+            </a:r>
+          </a:p>
+        </p:txBody>
+      </p:sp>
+      <p:sp>
+        <p:nvSpPr>
+          <p:cNvPr id="16" name="Rounded Rectangle 15"/>
           <p:cNvSpPr/>
           <p:nvPr/>
         </p:nvSpPr>
         <p:spPr>
           <a:xfrm>
-            <a:off x="6601968" y="1444752"/>
-            <a:ext cx="502920" cy="502920"/>
+            <a:off x="4261104" y="1143000"/>
+            <a:ext cx="3657600" cy="4983480"/>
           </a:xfrm>
           <a:prstGeom prst="roundRect">
             <a:avLst/>
           </a:prstGeom>
           <a:solidFill>
-            <a:srgbClr val="FFD75E"/>
+            <a:srgbClr val="EAF5FF"/>
           </a:solidFill>
           <a:ln>
             <a:noFill/>
@@ -3728,62 +3703,47 @@
           </a:p>
         </p:txBody>
       </p:sp>
-      <p:sp>
-        <p:nvSpPr>
-          <p:cNvPr id="18" name="TextBox 17"/>
-          <p:cNvSpPr txBox="1"/>
+      <p:pic>
+        <p:nvPicPr>
+          <p:cNvPr id="17" name="Picture 16" descr="tide-qiantang.jpg"/>
+          <p:cNvPicPr>
+            <a:picLocks noChangeAspect="1"/>
+          </p:cNvPicPr>
           <p:nvPr/>
-        </p:nvSpPr>
-        <p:spPr>
-          <a:xfrm>
-            <a:off x="6601968" y="1572768"/>
-            <a:ext cx="502920" cy="219456"/>
+        </p:nvPicPr>
+        <p:blipFill>
+          <a:blip r:embed="rId3"/>
+          <a:srcRect t="6159" b="6159"/>
+          <a:stretch>
+            <a:fillRect/>
+          </a:stretch>
+        </p:blipFill>
+        <p:spPr>
+          <a:xfrm>
+            <a:off x="4407408" y="1298448"/>
+            <a:ext cx="3364992" cy="2212848"/>
           </a:xfrm>
           <a:prstGeom prst="rect">
             <a:avLst/>
           </a:prstGeom>
-          <a:noFill/>
-        </p:spPr>
-        <p:txBody>
-          <a:bodyPr wrap="square" lIns="36576" rIns="36576" tIns="27432" bIns="27432">
-            <a:noAutofit/>
-          </a:bodyPr>
-          <a:lstStyle/>
-          <a:p>
-            <a:pPr algn="ctr">
-              <a:spcAft>
-                <a:spcPts val="0"/>
-              </a:spcAft>
-            </a:pPr>
-            <a:r>
-              <a:rPr sz="1500" b="1">
-                <a:solidFill>
-                  <a:srgbClr val="26384A"/>
-                </a:solidFill>
-                <a:latin typeface="PingFang SC"/>
-                <a:ea typeface="PingFang SC"/>
-              </a:rPr>
-              <a:t>2</a:t>
-            </a:r>
-          </a:p>
-        </p:txBody>
-      </p:sp>
-      <p:sp>
-        <p:nvSpPr>
-          <p:cNvPr id="19" name="Rounded Rectangle 18"/>
+        </p:spPr>
+      </p:pic>
+      <p:sp>
+        <p:nvSpPr>
+          <p:cNvPr id="18" name="Rounded Rectangle 17"/>
           <p:cNvSpPr/>
           <p:nvPr/>
         </p:nvSpPr>
         <p:spPr>
           <a:xfrm>
-            <a:off x="6656832" y="3337560"/>
-            <a:ext cx="4617720" cy="347472"/>
+            <a:off x="4553712" y="1444752"/>
+            <a:ext cx="502920" cy="502920"/>
           </a:xfrm>
           <a:prstGeom prst="roundRect">
             <a:avLst/>
           </a:prstGeom>
           <a:solidFill>
-            <a:srgbClr val="26384A"/>
+            <a:srgbClr val="FFD75E"/>
           </a:solidFill>
           <a:ln>
             <a:noFill/>
@@ -3814,14 +3774,14 @@
       </p:sp>
       <p:sp>
         <p:nvSpPr>
-          <p:cNvPr id="20" name="TextBox 19"/>
+          <p:cNvPr id="19" name="TextBox 18"/>
           <p:cNvSpPr txBox="1"/>
           <p:nvPr/>
         </p:nvSpPr>
         <p:spPr>
           <a:xfrm>
-            <a:off x="6766560" y="3419856"/>
-            <a:ext cx="4389120" cy="164592"/>
+            <a:off x="4553712" y="1572768"/>
+            <a:ext cx="502920" cy="219456"/>
           </a:xfrm>
           <a:prstGeom prst="rect">
             <a:avLst/>
@@ -3840,253 +3800,34 @@
               </a:spcAft>
             </a:pPr>
             <a:r>
-              <a:rPr sz="1000" b="1">
-                <a:solidFill>
-                  <a:srgbClr val="FFFFFF"/>
-                </a:solidFill>
-                <a:latin typeface="PingFang SC"/>
-                <a:ea typeface="PingFang SC"/>
-              </a:rPr>
-              <a:t>图里：科学家爷爷在海上研究海底</a:t>
-            </a:r>
-          </a:p>
-        </p:txBody>
-      </p:sp>
-      <p:sp>
-        <p:nvSpPr>
-          <p:cNvPr id="21" name="TextBox 20"/>
-          <p:cNvSpPr txBox="1"/>
-          <p:nvPr/>
-        </p:nvSpPr>
-        <p:spPr>
-          <a:xfrm>
-            <a:off x="6565392" y="3977639"/>
-            <a:ext cx="4754880" cy="457200"/>
-          </a:xfrm>
-          <a:prstGeom prst="rect">
-            <a:avLst/>
-          </a:prstGeom>
-          <a:noFill/>
-        </p:spPr>
-        <p:txBody>
-          <a:bodyPr wrap="square" lIns="36576" rIns="36576" tIns="27432" bIns="27432">
-            <a:noAutofit/>
-          </a:bodyPr>
-          <a:lstStyle/>
-          <a:p>
-            <a:pPr algn="l">
-              <a:spcAft>
-                <a:spcPts val="0"/>
-              </a:spcAft>
-            </a:pPr>
-            <a:r>
-              <a:rPr sz="2500" b="1">
+              <a:rPr sz="1500" b="1">
                 <a:solidFill>
                   <a:srgbClr val="26384A"/>
                 </a:solidFill>
                 <a:latin typeface="PingFang SC"/>
                 <a:ea typeface="PingFang SC"/>
               </a:rPr>
-              <a:t>科学家写来一封信</a:t>
-            </a:r>
-          </a:p>
-        </p:txBody>
-      </p:sp>
-      <p:sp>
-        <p:nvSpPr>
-          <p:cNvPr id="22" name="TextBox 21"/>
-          <p:cNvSpPr txBox="1"/>
-          <p:nvPr/>
-        </p:nvSpPr>
-        <p:spPr>
-          <a:xfrm>
-            <a:off x="6565392" y="4507992"/>
-            <a:ext cx="4754880" cy="640080"/>
-          </a:xfrm>
-          <a:prstGeom prst="rect">
-            <a:avLst/>
-          </a:prstGeom>
-          <a:noFill/>
-        </p:spPr>
-        <p:txBody>
-          <a:bodyPr wrap="square" lIns="36576" rIns="36576" tIns="27432" bIns="27432">
-            <a:noAutofit/>
-          </a:bodyPr>
-          <a:lstStyle/>
-          <a:p>
-            <a:pPr algn="l">
-              <a:spcAft>
-                <a:spcPts val="0"/>
-              </a:spcAft>
-            </a:pPr>
-            <a:r>
-              <a:rPr sz="1900" b="0">
-                <a:solidFill>
-                  <a:srgbClr val="26384A"/>
-                </a:solidFill>
-                <a:latin typeface="PingFang SC"/>
-                <a:ea typeface="PingFang SC"/>
-              </a:rPr>
-              <a:t>他想告诉小朋友：
-多问为什么，勇敢找答案。</a:t>
-            </a:r>
-          </a:p>
-        </p:txBody>
-      </p:sp>
-      <p:sp>
-        <p:nvSpPr>
-          <p:cNvPr id="23" name="TextBox 22"/>
-          <p:cNvSpPr txBox="1"/>
-          <p:nvPr/>
-        </p:nvSpPr>
-        <p:spPr>
-          <a:xfrm>
-            <a:off x="6565392" y="5367528"/>
-            <a:ext cx="4754880" cy="320040"/>
-          </a:xfrm>
-          <a:prstGeom prst="rect">
-            <a:avLst/>
-          </a:prstGeom>
-          <a:noFill/>
-        </p:spPr>
-        <p:txBody>
-          <a:bodyPr wrap="square" lIns="36576" rIns="36576" tIns="27432" bIns="27432">
-            <a:noAutofit/>
-          </a:bodyPr>
-          <a:lstStyle/>
-          <a:p>
-            <a:pPr algn="l">
-              <a:spcAft>
-                <a:spcPts val="0"/>
-              </a:spcAft>
-            </a:pPr>
-            <a:r>
-              <a:rPr sz="1600" b="1">
-                <a:solidFill>
-                  <a:srgbClr val="FF6475"/>
-                </a:solidFill>
-                <a:latin typeface="PingFang SC"/>
-                <a:ea typeface="PingFang SC"/>
-              </a:rPr>
-              <a:t>你想问他什么？</a:t>
-            </a:r>
-          </a:p>
-        </p:txBody>
-      </p:sp>
-      <p:sp>
-        <p:nvSpPr>
-          <p:cNvPr id="24" name="TextBox 23"/>
-          <p:cNvSpPr txBox="1"/>
-          <p:nvPr/>
-        </p:nvSpPr>
-        <p:spPr>
-          <a:xfrm>
-            <a:off x="594360" y="6446520"/>
-            <a:ext cx="8961120" cy="182880"/>
-          </a:xfrm>
-          <a:prstGeom prst="rect">
-            <a:avLst/>
-          </a:prstGeom>
-          <a:noFill/>
-        </p:spPr>
-        <p:txBody>
-          <a:bodyPr wrap="square" lIns="36576" rIns="36576" tIns="27432" bIns="27432">
-            <a:noAutofit/>
-          </a:bodyPr>
-          <a:lstStyle/>
-          <a:p>
-            <a:pPr algn="l">
-              <a:spcAft>
-                <a:spcPts val="0"/>
-              </a:spcAft>
-            </a:pPr>
-            <a:r>
-              <a:rPr sz="800" b="0">
-                <a:solidFill>
-                  <a:srgbClr val="617080"/>
-                </a:solidFill>
-                <a:latin typeface="PingFang SC"/>
-                <a:ea typeface="PingFang SC"/>
-              </a:rPr>
-              <a:t>新闻：新华社、中国科学院 · 2026年9月28日　图片：央视新闻、中国科学院</a:t>
-            </a:r>
-          </a:p>
-        </p:txBody>
-      </p:sp>
-      <p:sp>
-        <p:nvSpPr>
-          <p:cNvPr id="25" name="TextBox 24"/>
-          <p:cNvSpPr txBox="1"/>
-          <p:nvPr/>
-        </p:nvSpPr>
-        <p:spPr>
-          <a:xfrm>
-            <a:off x="10744200" y="6419088"/>
-            <a:ext cx="594360" cy="201168"/>
-          </a:xfrm>
-          <a:prstGeom prst="rect">
-            <a:avLst/>
-          </a:prstGeom>
-          <a:noFill/>
-        </p:spPr>
-        <p:txBody>
-          <a:bodyPr wrap="square" lIns="36576" rIns="36576" tIns="27432" bIns="27432">
-            <a:noAutofit/>
-          </a:bodyPr>
-          <a:lstStyle/>
-          <a:p>
-            <a:pPr algn="r">
-              <a:spcAft>
-                <a:spcPts val="0"/>
-              </a:spcAft>
-            </a:pPr>
-            <a:r>
-              <a:rPr sz="900" b="1">
-                <a:solidFill>
-                  <a:srgbClr val="617080"/>
-                </a:solidFill>
-                <a:latin typeface="PingFang SC"/>
-                <a:ea typeface="PingFang SC"/>
-              </a:rPr>
-              <a:t>1/2</a:t>
-            </a:r>
-          </a:p>
-        </p:txBody>
-      </p:sp>
-    </p:spTree>
-  </p:cSld>
-  <p:clrMapOvr>
-    <a:masterClrMapping/>
-  </p:clrMapOvr>
-</p:sld>
-</file>
-
-<file path=ppt/slides/slide2.xml><?xml version="1.0" encoding="utf-8"?>
-<p:sld xmlns:a="http://schemas.openxmlformats.org/drawingml/2006/main" xmlns:p="http://schemas.openxmlformats.org/presentationml/2006/main" xmlns:r="http://schemas.openxmlformats.org/officeDocument/2006/relationships">
-  <p:cSld>
-    <p:spTree>
-      <p:nvGrpSpPr>
-        <p:cNvPr id="1" name=""/>
-        <p:cNvGrpSpPr/>
-        <p:nvPr/>
-      </p:nvGrpSpPr>
-      <p:grpSpPr/>
-      <p:sp>
-        <p:nvSpPr>
-          <p:cNvPr id="2" name="Rectangle 1"/>
+              <a:t>2</a:t>
+            </a:r>
+          </a:p>
+        </p:txBody>
+      </p:sp>
+      <p:sp>
+        <p:nvSpPr>
+          <p:cNvPr id="20" name="Rounded Rectangle 19"/>
           <p:cNvSpPr/>
           <p:nvPr/>
         </p:nvSpPr>
         <p:spPr>
           <a:xfrm>
-            <a:off x="0" y="0"/>
-            <a:ext cx="12191695" cy="6858000"/>
-          </a:xfrm>
-          <a:prstGeom prst="rect">
+            <a:off x="4407408" y="3035808"/>
+            <a:ext cx="3364992" cy="365760"/>
+          </a:xfrm>
+          <a:prstGeom prst="roundRect">
             <a:avLst/>
           </a:prstGeom>
           <a:solidFill>
-            <a:srgbClr val="FFF9E8"/>
+            <a:srgbClr val="26384A"/>
           </a:solidFill>
           <a:ln>
             <a:noFill/>
@@ -4117,14 +3858,54 @@
       </p:sp>
       <p:sp>
         <p:nvSpPr>
-          <p:cNvPr id="3" name="TextBox 2"/>
+          <p:cNvPr id="21" name="TextBox 20"/>
           <p:cNvSpPr txBox="1"/>
           <p:nvPr/>
         </p:nvSpPr>
         <p:spPr>
           <a:xfrm>
-            <a:off x="594360" y="320040"/>
-            <a:ext cx="3931920" cy="502920"/>
+            <a:off x="4517136" y="3108960"/>
+            <a:ext cx="3154680" cy="201168"/>
+          </a:xfrm>
+          <a:prstGeom prst="rect">
+            <a:avLst/>
+          </a:prstGeom>
+          <a:noFill/>
+        </p:spPr>
+        <p:txBody>
+          <a:bodyPr wrap="square" lIns="36576" rIns="36576" tIns="27432" bIns="27432">
+            <a:noAutofit/>
+          </a:bodyPr>
+          <a:lstStyle/>
+          <a:p>
+            <a:pPr algn="ctr">
+              <a:spcAft>
+                <a:spcPts val="0"/>
+              </a:spcAft>
+            </a:pPr>
+            <a:r>
+              <a:rPr sz="1000" b="1">
+                <a:solidFill>
+                  <a:srgbClr val="FFFFFF"/>
+                </a:solidFill>
+                <a:latin typeface="PingFang SC"/>
+                <a:ea typeface="PingFang SC"/>
+              </a:rPr>
+              <a:t>图里：钱塘江一条白浪推着走</a:t>
+            </a:r>
+          </a:p>
+        </p:txBody>
+      </p:sp>
+      <p:sp>
+        <p:nvSpPr>
+          <p:cNvPr id="22" name="TextBox 21"/>
+          <p:cNvSpPr txBox="1"/>
+          <p:nvPr/>
+        </p:nvSpPr>
+        <p:spPr>
+          <a:xfrm>
+            <a:off x="4425696" y="3611880"/>
+            <a:ext cx="3337560" cy="777240"/>
           </a:xfrm>
           <a:prstGeom prst="rect">
             <a:avLst/>
@@ -4143,28 +3924,70 @@
               </a:spcAft>
             </a:pPr>
             <a:r>
-              <a:rPr sz="2800" b="1">
+              <a:rPr sz="2200" b="1">
                 <a:solidFill>
                   <a:srgbClr val="26384A"/>
                 </a:solidFill>
                 <a:latin typeface="PingFang SC"/>
                 <a:ea typeface="PingFang SC"/>
               </a:rPr>
-              <a:t>小小新闻</a:t>
-            </a:r>
-          </a:p>
-        </p:txBody>
-      </p:sp>
-      <p:sp>
-        <p:nvSpPr>
-          <p:cNvPr id="4" name="Rounded Rectangle 3"/>
+              <a:t>钱塘江大潮像白线一样</a:t>
+            </a:r>
+          </a:p>
+        </p:txBody>
+      </p:sp>
+      <p:sp>
+        <p:nvSpPr>
+          <p:cNvPr id="23" name="TextBox 22"/>
+          <p:cNvSpPr txBox="1"/>
+          <p:nvPr/>
+        </p:nvSpPr>
+        <p:spPr>
+          <a:xfrm>
+            <a:off x="4425696" y="4416552"/>
+            <a:ext cx="3337560" cy="1280160"/>
+          </a:xfrm>
+          <a:prstGeom prst="rect">
+            <a:avLst/>
+          </a:prstGeom>
+          <a:noFill/>
+        </p:spPr>
+        <p:txBody>
+          <a:bodyPr wrap="square" lIns="36576" rIns="36576" tIns="27432" bIns="27432">
+            <a:noAutofit/>
+          </a:bodyPr>
+          <a:lstStyle/>
+          <a:p>
+            <a:pPr algn="l">
+              <a:spcAft>
+                <a:spcPts val="0"/>
+              </a:spcAft>
+            </a:pPr>
+            <a:r>
+              <a:rPr sz="1600" b="0">
+                <a:solidFill>
+                  <a:srgbClr val="26384A"/>
+                </a:solidFill>
+                <a:latin typeface="PingFang SC"/>
+                <a:ea typeface="PingFang SC"/>
+              </a:rPr>
+              <a:t>一条白白浪花，
+推着江面往前走。
+小朋友们大声说：好厉害！</a:t>
+            </a:r>
+          </a:p>
+        </p:txBody>
+      </p:sp>
+      <p:sp>
+        <p:nvSpPr>
+          <p:cNvPr id="24" name="Rounded Rectangle 23"/>
           <p:cNvSpPr/>
           <p:nvPr/>
         </p:nvSpPr>
         <p:spPr>
           <a:xfrm>
-            <a:off x="6720840" y="310896"/>
-            <a:ext cx="4846320" cy="475488"/>
+            <a:off x="4425696" y="5486400"/>
+            <a:ext cx="3337560" cy="457200"/>
           </a:xfrm>
           <a:prstGeom prst="roundRect">
             <a:avLst/>
@@ -4201,14 +4024,14 @@
       </p:sp>
       <p:sp>
         <p:nvSpPr>
-          <p:cNvPr id="5" name="TextBox 4"/>
+          <p:cNvPr id="25" name="TextBox 24"/>
           <p:cNvSpPr txBox="1"/>
           <p:nvPr/>
         </p:nvSpPr>
         <p:spPr>
           <a:xfrm>
-            <a:off x="6885432" y="420624"/>
-            <a:ext cx="4526280" cy="210312"/>
+            <a:off x="4517136" y="5596128"/>
+            <a:ext cx="3154680" cy="256032"/>
           </a:xfrm>
           <a:prstGeom prst="rect">
             <a:avLst/>
@@ -4221,65 +4044,40 @@
           </a:bodyPr>
           <a:lstStyle/>
           <a:p>
-            <a:pPr algn="ctr">
+            <a:pPr algn="l">
               <a:spcAft>
                 <a:spcPts val="0"/>
               </a:spcAft>
             </a:pPr>
             <a:r>
-              <a:rPr sz="1100" b="1">
+              <a:rPr sz="1500" b="1">
                 <a:solidFill>
-                  <a:srgbClr val="26384A"/>
+                  <a:srgbClr val="FF6475"/>
                 </a:solidFill>
                 <a:latin typeface="PingFang SC"/>
                 <a:ea typeface="PingFang SC"/>
               </a:rPr>
-              <a:t>9月29日 星期二　上海 阴天 21—25℃，可能有小雨</a:t>
-            </a:r>
-          </a:p>
-        </p:txBody>
-      </p:sp>
-      <p:pic>
-        <p:nvPicPr>
-          <p:cNvPr id="6" name="Picture 5" descr="tide-three-waves.jpg"/>
-          <p:cNvPicPr>
-            <a:picLocks noChangeAspect="1"/>
-          </p:cNvPicPr>
-          <p:nvPr/>
-        </p:nvPicPr>
-        <p:blipFill>
-          <a:blip r:embed="rId2"/>
-          <a:srcRect t="28013" b="28013"/>
-          <a:stretch>
-            <a:fillRect/>
-          </a:stretch>
-        </p:blipFill>
-        <p:spPr>
-          <a:xfrm>
-            <a:off x="594360" y="1170432"/>
-            <a:ext cx="6675120" cy="4709160"/>
-          </a:xfrm>
-          <a:prstGeom prst="rect">
-            <a:avLst/>
-          </a:prstGeom>
-        </p:spPr>
-      </p:pic>
-      <p:sp>
-        <p:nvSpPr>
-          <p:cNvPr id="7" name="Rounded Rectangle 6"/>
+              <a:t>你觉得它像什么？</a:t>
+            </a:r>
+          </a:p>
+        </p:txBody>
+      </p:sp>
+      <p:sp>
+        <p:nvSpPr>
+          <p:cNvPr id="26" name="Rounded Rectangle 25"/>
           <p:cNvSpPr/>
           <p:nvPr/>
         </p:nvSpPr>
         <p:spPr>
           <a:xfrm>
-            <a:off x="804672" y="1389888"/>
-            <a:ext cx="530352" cy="530352"/>
+            <a:off x="8019288" y="1143000"/>
+            <a:ext cx="3657600" cy="4983480"/>
           </a:xfrm>
           <a:prstGeom prst="roundRect">
             <a:avLst/>
           </a:prstGeom>
           <a:solidFill>
-            <a:srgbClr val="FFD75E"/>
+            <a:srgbClr val="FFF0E7"/>
           </a:solidFill>
           <a:ln>
             <a:noFill/>
@@ -4308,62 +4106,47 @@
           </a:p>
         </p:txBody>
       </p:sp>
-      <p:sp>
-        <p:nvSpPr>
-          <p:cNvPr id="8" name="TextBox 7"/>
-          <p:cNvSpPr txBox="1"/>
+      <p:pic>
+        <p:nvPicPr>
+          <p:cNvPr id="27" name="Picture 26" descr="moon-autumn.jpg"/>
+          <p:cNvPicPr>
+            <a:picLocks noChangeAspect="1"/>
+          </p:cNvPicPr>
           <p:nvPr/>
-        </p:nvSpPr>
-        <p:spPr>
-          <a:xfrm>
-            <a:off x="804672" y="1527048"/>
-            <a:ext cx="530352" cy="219456"/>
+        </p:nvPicPr>
+        <p:blipFill>
+          <a:blip r:embed="rId4"/>
+          <a:srcRect t="3495" b="3495"/>
+          <a:stretch>
+            <a:fillRect/>
+          </a:stretch>
+        </p:blipFill>
+        <p:spPr>
+          <a:xfrm>
+            <a:off x="8165592" y="1298448"/>
+            <a:ext cx="3364992" cy="2212848"/>
           </a:xfrm>
           <a:prstGeom prst="rect">
             <a:avLst/>
           </a:prstGeom>
-          <a:noFill/>
-        </p:spPr>
-        <p:txBody>
-          <a:bodyPr wrap="square" lIns="36576" rIns="36576" tIns="27432" bIns="27432">
-            <a:noAutofit/>
-          </a:bodyPr>
-          <a:lstStyle/>
-          <a:p>
-            <a:pPr algn="ctr">
-              <a:spcAft>
-                <a:spcPts val="0"/>
-              </a:spcAft>
-            </a:pPr>
-            <a:r>
-              <a:rPr sz="1600" b="1">
-                <a:solidFill>
-                  <a:srgbClr val="26384A"/>
-                </a:solidFill>
-                <a:latin typeface="PingFang SC"/>
-                <a:ea typeface="PingFang SC"/>
-              </a:rPr>
-              <a:t>3</a:t>
-            </a:r>
-          </a:p>
-        </p:txBody>
-      </p:sp>
-      <p:sp>
-        <p:nvSpPr>
-          <p:cNvPr id="9" name="Rounded Rectangle 8"/>
+        </p:spPr>
+      </p:pic>
+      <p:sp>
+        <p:nvSpPr>
+          <p:cNvPr id="28" name="Rounded Rectangle 27"/>
           <p:cNvSpPr/>
           <p:nvPr/>
         </p:nvSpPr>
         <p:spPr>
           <a:xfrm>
-            <a:off x="932688" y="5230368"/>
-            <a:ext cx="5989320" cy="384048"/>
+            <a:off x="8311896" y="1444752"/>
+            <a:ext cx="502920" cy="502920"/>
           </a:xfrm>
           <a:prstGeom prst="roundRect">
             <a:avLst/>
           </a:prstGeom>
           <a:solidFill>
-            <a:srgbClr val="26384A"/>
+            <a:srgbClr val="FFD75E"/>
           </a:solidFill>
           <a:ln>
             <a:noFill/>
@@ -4394,14 +4177,14 @@
       </p:sp>
       <p:sp>
         <p:nvSpPr>
-          <p:cNvPr id="10" name="TextBox 9"/>
+          <p:cNvPr id="29" name="TextBox 28"/>
           <p:cNvSpPr txBox="1"/>
           <p:nvPr/>
         </p:nvSpPr>
         <p:spPr>
           <a:xfrm>
-            <a:off x="1097280" y="5321808"/>
-            <a:ext cx="5669280" cy="182880"/>
+            <a:off x="8311896" y="1572768"/>
+            <a:ext cx="502920" cy="219456"/>
           </a:xfrm>
           <a:prstGeom prst="rect">
             <a:avLst/>
@@ -4420,115 +4203,34 @@
               </a:spcAft>
             </a:pPr>
             <a:r>
-              <a:rPr sz="1200" b="1">
-                <a:solidFill>
-                  <a:srgbClr val="FFFFFF"/>
-                </a:solidFill>
-                <a:latin typeface="PingFang SC"/>
-                <a:ea typeface="PingFang SC"/>
-              </a:rPr>
-              <a:t>图里：钱塘江三条白色浪花正在碰到一起</a:t>
-            </a:r>
-          </a:p>
-        </p:txBody>
-      </p:sp>
-      <p:sp>
-        <p:nvSpPr>
-          <p:cNvPr id="11" name="TextBox 10"/>
-          <p:cNvSpPr txBox="1"/>
-          <p:nvPr/>
-        </p:nvSpPr>
-        <p:spPr>
-          <a:xfrm>
-            <a:off x="7699248" y="1389888"/>
-            <a:ext cx="3749039" cy="960120"/>
-          </a:xfrm>
-          <a:prstGeom prst="rect">
-            <a:avLst/>
-          </a:prstGeom>
-          <a:noFill/>
-        </p:spPr>
-        <p:txBody>
-          <a:bodyPr wrap="square" lIns="36576" rIns="36576" tIns="27432" bIns="27432">
-            <a:noAutofit/>
-          </a:bodyPr>
-          <a:lstStyle/>
-          <a:p>
-            <a:pPr algn="l">
-              <a:spcAft>
-                <a:spcPts val="0"/>
-              </a:spcAft>
-            </a:pPr>
-            <a:r>
-              <a:rPr sz="2700" b="1">
+              <a:rPr sz="1500" b="1">
                 <a:solidFill>
                   <a:srgbClr val="26384A"/>
                 </a:solidFill>
                 <a:latin typeface="PingFang SC"/>
                 <a:ea typeface="PingFang SC"/>
               </a:rPr>
-              <a:t>钱塘江三股潮水相遇</a:t>
-            </a:r>
-          </a:p>
-        </p:txBody>
-      </p:sp>
-      <p:sp>
-        <p:nvSpPr>
-          <p:cNvPr id="12" name="TextBox 11"/>
-          <p:cNvSpPr txBox="1"/>
-          <p:nvPr/>
-        </p:nvSpPr>
-        <p:spPr>
-          <a:xfrm>
-            <a:off x="7699248" y="2560320"/>
-            <a:ext cx="3749039" cy="1143000"/>
-          </a:xfrm>
-          <a:prstGeom prst="rect">
-            <a:avLst/>
-          </a:prstGeom>
-          <a:noFill/>
-        </p:spPr>
-        <p:txBody>
-          <a:bodyPr wrap="square" lIns="36576" rIns="36576" tIns="27432" bIns="27432">
-            <a:noAutofit/>
-          </a:bodyPr>
-          <a:lstStyle/>
-          <a:p>
-            <a:pPr algn="l">
-              <a:spcAft>
-                <a:spcPts val="0"/>
-              </a:spcAft>
-            </a:pPr>
-            <a:r>
-              <a:rPr sz="2400" b="0">
-                <a:solidFill>
-                  <a:srgbClr val="26384A"/>
-                </a:solidFill>
-                <a:latin typeface="PingFang SC"/>
-                <a:ea typeface="PingFang SC"/>
-              </a:rPr>
-              <a:t>三条浪花碰在一起，
-像一只大大的蝴蝶。</a:t>
-            </a:r>
-          </a:p>
-        </p:txBody>
-      </p:sp>
-      <p:sp>
-        <p:nvSpPr>
-          <p:cNvPr id="13" name="Rounded Rectangle 12"/>
+              <a:t>3</a:t>
+            </a:r>
+          </a:p>
+        </p:txBody>
+      </p:sp>
+      <p:sp>
+        <p:nvSpPr>
+          <p:cNvPr id="30" name="Rounded Rectangle 29"/>
           <p:cNvSpPr/>
           <p:nvPr/>
         </p:nvSpPr>
         <p:spPr>
           <a:xfrm>
-            <a:off x="7699248" y="4114800"/>
-            <a:ext cx="3794760" cy="749808"/>
+            <a:off x="8165592" y="3035808"/>
+            <a:ext cx="3364992" cy="365760"/>
           </a:xfrm>
           <a:prstGeom prst="roundRect">
             <a:avLst/>
           </a:prstGeom>
           <a:solidFill>
-            <a:srgbClr val="FFFFFF"/>
+            <a:srgbClr val="26384A"/>
           </a:solidFill>
           <a:ln>
             <a:noFill/>
@@ -4559,14 +4261,54 @@
       </p:sp>
       <p:sp>
         <p:nvSpPr>
-          <p:cNvPr id="14" name="TextBox 13"/>
+          <p:cNvPr id="31" name="TextBox 30"/>
           <p:cNvSpPr txBox="1"/>
           <p:nvPr/>
         </p:nvSpPr>
         <p:spPr>
           <a:xfrm>
-            <a:off x="7900416" y="4315968"/>
-            <a:ext cx="3401568" cy="292608"/>
+            <a:off x="8275319" y="3108960"/>
+            <a:ext cx="3154680" cy="201168"/>
+          </a:xfrm>
+          <a:prstGeom prst="rect">
+            <a:avLst/>
+          </a:prstGeom>
+          <a:noFill/>
+        </p:spPr>
+        <p:txBody>
+          <a:bodyPr wrap="square" lIns="36576" rIns="36576" tIns="27432" bIns="27432">
+            <a:noAutofit/>
+          </a:bodyPr>
+          <a:lstStyle/>
+          <a:p>
+            <a:pPr algn="ctr">
+              <a:spcAft>
+                <a:spcPts val="0"/>
+              </a:spcAft>
+            </a:pPr>
+            <a:r>
+              <a:rPr sz="1000" b="1">
+                <a:solidFill>
+                  <a:srgbClr val="FFFFFF"/>
+                </a:solidFill>
+                <a:latin typeface="PingFang SC"/>
+                <a:ea typeface="PingFang SC"/>
+              </a:rPr>
+              <a:t>图里：一轮又大又圆的月亮挂在天上</a:t>
+            </a:r>
+          </a:p>
+        </p:txBody>
+      </p:sp>
+      <p:sp>
+        <p:nvSpPr>
+          <p:cNvPr id="32" name="TextBox 31"/>
+          <p:cNvSpPr txBox="1"/>
+          <p:nvPr/>
+        </p:nvSpPr>
+        <p:spPr>
+          <a:xfrm>
+            <a:off x="8183879" y="3611880"/>
+            <a:ext cx="3337560" cy="777240"/>
           </a:xfrm>
           <a:prstGeom prst="rect">
             <a:avLst/>
@@ -4585,68 +4327,154 @@
               </a:spcAft>
             </a:pPr>
             <a:r>
-              <a:rPr sz="1800" b="1">
+              <a:rPr sz="2200" b="1">
+                <a:solidFill>
+                  <a:srgbClr val="26384A"/>
+                </a:solidFill>
+                <a:latin typeface="PingFang SC"/>
+                <a:ea typeface="PingFang SC"/>
+              </a:rPr>
+              <a:t>中秋的大月亮又圆又大</a:t>
+            </a:r>
+          </a:p>
+        </p:txBody>
+      </p:sp>
+      <p:sp>
+        <p:nvSpPr>
+          <p:cNvPr id="33" name="TextBox 32"/>
+          <p:cNvSpPr txBox="1"/>
+          <p:nvPr/>
+        </p:nvSpPr>
+        <p:spPr>
+          <a:xfrm>
+            <a:off x="8183879" y="4416552"/>
+            <a:ext cx="3337560" cy="1280160"/>
+          </a:xfrm>
+          <a:prstGeom prst="rect">
+            <a:avLst/>
+          </a:prstGeom>
+          <a:noFill/>
+        </p:spPr>
+        <p:txBody>
+          <a:bodyPr wrap="square" lIns="36576" rIns="36576" tIns="27432" bIns="27432">
+            <a:noAutofit/>
+          </a:bodyPr>
+          <a:lstStyle/>
+          <a:p>
+            <a:pPr algn="l">
+              <a:spcAft>
+                <a:spcPts val="0"/>
+              </a:spcAft>
+            </a:pPr>
+            <a:r>
+              <a:rPr sz="1600" b="0">
+                <a:solidFill>
+                  <a:srgbClr val="26384A"/>
+                </a:solidFill>
+                <a:latin typeface="PingFang SC"/>
+                <a:ea typeface="PingFang SC"/>
+              </a:rPr>
+              <a:t>今年最圆的月亮，
+比中秋晚两天才来。
+抬头看一看，有小白兔。</a:t>
+            </a:r>
+          </a:p>
+        </p:txBody>
+      </p:sp>
+      <p:sp>
+        <p:nvSpPr>
+          <p:cNvPr id="34" name="Rounded Rectangle 33"/>
+          <p:cNvSpPr/>
+          <p:nvPr/>
+        </p:nvSpPr>
+        <p:spPr>
+          <a:xfrm>
+            <a:off x="8183879" y="5486400"/>
+            <a:ext cx="3337560" cy="457200"/>
+          </a:xfrm>
+          <a:prstGeom prst="roundRect">
+            <a:avLst/>
+          </a:prstGeom>
+          <a:solidFill>
+            <a:srgbClr val="FFFFFF"/>
+          </a:solidFill>
+          <a:ln>
+            <a:noFill/>
+          </a:ln>
+          <a:effectLst/>
+        </p:spPr>
+        <p:style>
+          <a:lnRef idx="1">
+            <a:schemeClr val="accent1"/>
+          </a:lnRef>
+          <a:fillRef idx="3">
+            <a:schemeClr val="accent1"/>
+          </a:fillRef>
+          <a:effectRef idx="2">
+            <a:schemeClr val="accent1"/>
+          </a:effectRef>
+          <a:fontRef idx="minor">
+            <a:schemeClr val="lt1"/>
+          </a:fontRef>
+        </p:style>
+        <p:txBody>
+          <a:bodyPr rtlCol="0" anchor="ctr"/>
+          <a:lstStyle/>
+          <a:p>
+            <a:pPr algn="ctr"/>
+          </a:p>
+        </p:txBody>
+      </p:sp>
+      <p:sp>
+        <p:nvSpPr>
+          <p:cNvPr id="35" name="TextBox 34"/>
+          <p:cNvSpPr txBox="1"/>
+          <p:nvPr/>
+        </p:nvSpPr>
+        <p:spPr>
+          <a:xfrm>
+            <a:off x="8275319" y="5596128"/>
+            <a:ext cx="3154680" cy="256032"/>
+          </a:xfrm>
+          <a:prstGeom prst="rect">
+            <a:avLst/>
+          </a:prstGeom>
+          <a:noFill/>
+        </p:spPr>
+        <p:txBody>
+          <a:bodyPr wrap="square" lIns="36576" rIns="36576" tIns="27432" bIns="27432">
+            <a:noAutofit/>
+          </a:bodyPr>
+          <a:lstStyle/>
+          <a:p>
+            <a:pPr algn="l">
+              <a:spcAft>
+                <a:spcPts val="0"/>
+              </a:spcAft>
+            </a:pPr>
+            <a:r>
+              <a:rPr sz="1500" b="1">
                 <a:solidFill>
                   <a:srgbClr val="FF6475"/>
                 </a:solidFill>
                 <a:latin typeface="PingFang SC"/>
                 <a:ea typeface="PingFang SC"/>
               </a:rPr>
-              <a:t>你觉得它还像什么？</a:t>
-            </a:r>
-          </a:p>
-        </p:txBody>
-      </p:sp>
-      <p:sp>
-        <p:nvSpPr>
-          <p:cNvPr id="15" name="TextBox 14"/>
+              <a:t>你看到了什么？</a:t>
+            </a:r>
+          </a:p>
+        </p:txBody>
+      </p:sp>
+      <p:sp>
+        <p:nvSpPr>
+          <p:cNvPr id="36" name="TextBox 35"/>
           <p:cNvSpPr txBox="1"/>
           <p:nvPr/>
         </p:nvSpPr>
         <p:spPr>
           <a:xfrm>
-            <a:off x="7699248" y="5257800"/>
-            <a:ext cx="3657600" cy="548640"/>
-          </a:xfrm>
-          <a:prstGeom prst="rect">
-            <a:avLst/>
-          </a:prstGeom>
-          <a:noFill/>
-        </p:spPr>
-        <p:txBody>
-          <a:bodyPr wrap="square" lIns="36576" rIns="36576" tIns="27432" bIns="27432">
-            <a:noAutofit/>
-          </a:bodyPr>
-          <a:lstStyle/>
-          <a:p>
-            <a:pPr algn="l">
-              <a:spcAft>
-                <a:spcPts val="0"/>
-              </a:spcAft>
-            </a:pPr>
-            <a:r>
-              <a:rPr sz="1500" b="1">
-                <a:solidFill>
-                  <a:srgbClr val="617080"/>
-                </a:solidFill>
-                <a:latin typeface="PingFang SC"/>
-                <a:ea typeface="PingFang SC"/>
-              </a:rPr>
-              <a:t>选一条你最喜欢的新闻讲给大家听。</a:t>
-            </a:r>
-          </a:p>
-        </p:txBody>
-      </p:sp>
-      <p:sp>
-        <p:nvSpPr>
-          <p:cNvPr id="16" name="TextBox 15"/>
-          <p:cNvSpPr txBox="1"/>
-          <p:nvPr/>
-        </p:nvSpPr>
-        <p:spPr>
-          <a:xfrm>
             <a:off x="594360" y="6446520"/>
-            <a:ext cx="8961120" cy="182880"/>
+            <a:ext cx="10972800" cy="182880"/>
           </a:xfrm>
           <a:prstGeom prst="rect">
             <a:avLst/>
@@ -4672,14 +4500,14 @@
                 <a:latin typeface="PingFang SC"/>
                 <a:ea typeface="PingFang SC"/>
               </a:rPr>
-              <a:t>新闻与图片：杭州网 · 2026年9月27日</a:t>
-            </a:r>
-          </a:p>
-        </p:txBody>
-      </p:sp>
-      <p:sp>
-        <p:nvSpPr>
-          <p:cNvPr id="17" name="TextBox 16"/>
+              <a:t>新闻：新华社、央视新闻 · 2026年9月24—28日　图片：央视新闻、视觉中国、中评网</a:t>
+            </a:r>
+          </a:p>
+        </p:txBody>
+      </p:sp>
+      <p:sp>
+        <p:nvSpPr>
+          <p:cNvPr id="37" name="TextBox 36"/>
           <p:cNvSpPr txBox="1"/>
           <p:nvPr/>
         </p:nvSpPr>
@@ -4712,7 +4540,7 @@
                 <a:latin typeface="PingFang SC"/>
                 <a:ea typeface="PingFang SC"/>
               </a:rPr>
-              <a:t>2/2</a:t>
+              <a:t>1/1</a:t>
             </a:r>
           </a:p>
         </p:txBody>

</xml_diff>